<commit_message>
Show increases and decreases in the waterfall example
Rebuild the waterfall as Base (invisible), Total, Increase and Decrease
series with a negative step (80 +15 +10 -8 = 97). Fills are theme
colours: totals a neutral 50% shade of bg1, increases accent1,
decreases accent2, so the chart recolours on paste. Labels stay native;
signs come from the number format and zero labels are hidden. The
legend hides the Base entry.

The verifier now requires the four series, theme-colour fills, distinct
colours, at least one increase and one decrease, and arithmetic that
adds up. Tests cover each rule.

Co-Authored-By: Claude Opus 5.5 <noreply@anthropic.com>
Claude-Session: https://claude.ai/code/session_015CGqyR4kAxLaHwWEURe8sB
</commit_message>
<xml_diff>
--- a/references/plain-fallback-layouts.pptx
+++ b/references/plain-fallback-layouts.pptx
@@ -1459,19 +1459,19 @@
                 <c:formatCode>0</c:formatCode>
                 <c:ptCount val="5"/>
                 <c:pt idx="0">
-                  <c:v>0</c:v>
+                  <c:v>0.0</c:v>
                 </c:pt>
                 <c:pt idx="1">
-                  <c:v>80</c:v>
+                  <c:v>80.0</c:v>
                 </c:pt>
                 <c:pt idx="2">
-                  <c:v>95</c:v>
+                  <c:v>95.0</c:v>
                 </c:pt>
                 <c:pt idx="3">
-                  <c:v>105</c:v>
+                  <c:v>97.0</c:v>
                 </c:pt>
                 <c:pt idx="4">
-                  <c:v>0</c:v>
+                  <c:v>0.0</c:v>
                 </c:pt>
               </c:numCache>
             </c:numRef>
@@ -1486,106 +1486,23 @@
               <c:strCache>
                 <c:ptCount val="1"/>
                 <c:pt idx="0">
-                  <c:v>Movement</c:v>
+                  <c:v>Total</c:v>
                 </c:pt>
               </c:strCache>
             </c:strRef>
           </c:tx>
+          <c:spPr>
+            <a:solidFill>
+              <a:schemeClr val="bg1">
+                <a:lumMod val="50000"/>
+              </a:schemeClr>
+            </a:solidFill>
+            <a:ln>
+              <a:noFill/>
+            </a:ln>
+          </c:spPr>
           <c:dLbls>
-            <c:dLbl>
-              <c:idx val="1"/>
-              <c:numFmt formatCode="+0;-0;0" sourceLinked="0"/>
-              <c:spPr>
-                <a:noFill/>
-                <a:ln>
-                  <a:noFill/>
-                </a:ln>
-              </c:spPr>
-              <c:txPr>
-                <a:bodyPr/>
-                <a:lstStyle/>
-                <a:p>
-                  <a:pPr>
-                    <a:defRPr>
-                      <a:solidFill>
-                        <a:schemeClr val="bg1"/>
-                      </a:solidFill>
-                    </a:defRPr>
-                  </a:pPr>
-                  <a:endParaRPr lang="en-GB"/>
-                </a:p>
-              </c:txPr>
-              <c:dLblPos val="ctr"/>
-              <c:showLegendKey val="0"/>
-              <c:showVal val="1"/>
-              <c:showCatName val="0"/>
-              <c:showSerName val="0"/>
-              <c:showPercent val="0"/>
-              <c:showBubbleSize val="0"/>
-            </c:dLbl>
-            <c:dLbl>
-              <c:idx val="2"/>
-              <c:numFmt formatCode="+0;-0;0" sourceLinked="0"/>
-              <c:spPr>
-                <a:noFill/>
-                <a:ln>
-                  <a:noFill/>
-                </a:ln>
-              </c:spPr>
-              <c:txPr>
-                <a:bodyPr/>
-                <a:lstStyle/>
-                <a:p>
-                  <a:pPr>
-                    <a:defRPr>
-                      <a:solidFill>
-                        <a:schemeClr val="bg1"/>
-                      </a:solidFill>
-                    </a:defRPr>
-                  </a:pPr>
-                  <a:endParaRPr lang="en-GB"/>
-                </a:p>
-              </c:txPr>
-              <c:dLblPos val="ctr"/>
-              <c:showLegendKey val="0"/>
-              <c:showVal val="1"/>
-              <c:showCatName val="0"/>
-              <c:showSerName val="0"/>
-              <c:showPercent val="0"/>
-              <c:showBubbleSize val="0"/>
-            </c:dLbl>
-            <c:dLbl>
-              <c:idx val="3"/>
-              <c:numFmt formatCode="+0;-0;0" sourceLinked="0"/>
-              <c:spPr>
-                <a:noFill/>
-                <a:ln>
-                  <a:noFill/>
-                </a:ln>
-              </c:spPr>
-              <c:txPr>
-                <a:bodyPr/>
-                <a:lstStyle/>
-                <a:p>
-                  <a:pPr>
-                    <a:defRPr>
-                      <a:solidFill>
-                        <a:schemeClr val="bg1"/>
-                      </a:solidFill>
-                    </a:defRPr>
-                  </a:pPr>
-                  <a:endParaRPr lang="en-GB"/>
-                </a:p>
-              </c:txPr>
-              <c:dLblPos val="ctr"/>
-              <c:showLegendKey val="0"/>
-              <c:showVal val="1"/>
-              <c:showCatName val="0"/>
-              <c:showSerName val="0"/>
-              <c:showPercent val="0"/>
-              <c:showBubbleSize val="0"/>
-            </c:dLbl>
-            <c:numFmt formatCode="0" sourceLinked="0"/>
+            <c:numFmt formatCode="#,##0;;;" sourceLinked="0"/>
             <c:spPr>
               <a:noFill/>
               <a:ln>
@@ -1644,19 +1561,219 @@
                 <c:formatCode>0</c:formatCode>
                 <c:ptCount val="5"/>
                 <c:pt idx="0">
-                  <c:v>80</c:v>
+                  <c:v>80.0</c:v>
                 </c:pt>
                 <c:pt idx="1">
-                  <c:v>15</c:v>
+                  <c:v>0.0</c:v>
                 </c:pt>
                 <c:pt idx="2">
-                  <c:v>10</c:v>
+                  <c:v>0.0</c:v>
                 </c:pt>
                 <c:pt idx="3">
-                  <c:v>12</c:v>
+                  <c:v>0.0</c:v>
                 </c:pt>
                 <c:pt idx="4">
-                  <c:v>117</c:v>
+                  <c:v>97.0</c:v>
+                </c:pt>
+              </c:numCache>
+            </c:numRef>
+          </c:val>
+        </c:ser>
+        <c:ser>
+          <c:idx val="2"/>
+          <c:order val="2"/>
+          <c:tx>
+            <c:strRef>
+              <c:f>Sheet1!$D$1</c:f>
+              <c:strCache>
+                <c:ptCount val="1"/>
+                <c:pt idx="0">
+                  <c:v>Increase</c:v>
+                </c:pt>
+              </c:strCache>
+            </c:strRef>
+          </c:tx>
+          <c:spPr>
+            <a:solidFill>
+              <a:schemeClr val="accent1"/>
+            </a:solidFill>
+            <a:ln>
+              <a:noFill/>
+            </a:ln>
+          </c:spPr>
+          <c:dLbls>
+            <c:numFmt formatCode="+#,##0;;;" sourceLinked="0"/>
+            <c:spPr>
+              <a:noFill/>
+              <a:ln>
+                <a:noFill/>
+              </a:ln>
+            </c:spPr>
+            <c:txPr>
+              <a:bodyPr/>
+              <a:lstStyle/>
+              <a:p>
+                <a:pPr>
+                  <a:defRPr>
+                    <a:solidFill>
+                      <a:schemeClr val="bg1"/>
+                    </a:solidFill>
+                  </a:defRPr>
+                </a:pPr>
+                <a:endParaRPr lang="en-GB"/>
+              </a:p>
+            </c:txPr>
+            <c:dLblPos val="ctr"/>
+            <c:showLegendKey val="0"/>
+            <c:showVal val="1"/>
+            <c:showCatName val="0"/>
+            <c:showSerName val="0"/>
+            <c:showPercent val="0"/>
+            <c:showBubbleSize val="0"/>
+          </c:dLbls>
+          <c:cat>
+            <c:strRef>
+              <c:f>Sheet1!$A$2:$A$6</c:f>
+              <c:strCache>
+                <c:ptCount val="5"/>
+                <c:pt idx="0">
+                  <c:v>2025 profit</c:v>
+                </c:pt>
+                <c:pt idx="1">
+                  <c:v>Volume</c:v>
+                </c:pt>
+                <c:pt idx="2">
+                  <c:v>Price</c:v>
+                </c:pt>
+                <c:pt idx="3">
+                  <c:v>Costs</c:v>
+                </c:pt>
+                <c:pt idx="4">
+                  <c:v>2026 profit</c:v>
+                </c:pt>
+              </c:strCache>
+            </c:strRef>
+          </c:cat>
+          <c:val>
+            <c:numRef>
+              <c:f>Sheet1!$D$2:$D$6</c:f>
+              <c:numCache>
+                <c:formatCode>0</c:formatCode>
+                <c:ptCount val="5"/>
+                <c:pt idx="0">
+                  <c:v>0.0</c:v>
+                </c:pt>
+                <c:pt idx="1">
+                  <c:v>15.0</c:v>
+                </c:pt>
+                <c:pt idx="2">
+                  <c:v>10.0</c:v>
+                </c:pt>
+                <c:pt idx="3">
+                  <c:v>0.0</c:v>
+                </c:pt>
+                <c:pt idx="4">
+                  <c:v>0.0</c:v>
+                </c:pt>
+              </c:numCache>
+            </c:numRef>
+          </c:val>
+        </c:ser>
+        <c:ser>
+          <c:idx val="3"/>
+          <c:order val="3"/>
+          <c:tx>
+            <c:strRef>
+              <c:f>Sheet1!$E$1</c:f>
+              <c:strCache>
+                <c:ptCount val="1"/>
+                <c:pt idx="0">
+                  <c:v>Decrease</c:v>
+                </c:pt>
+              </c:strCache>
+            </c:strRef>
+          </c:tx>
+          <c:spPr>
+            <a:solidFill>
+              <a:schemeClr val="accent2"/>
+            </a:solidFill>
+            <a:ln>
+              <a:noFill/>
+            </a:ln>
+          </c:spPr>
+          <c:dLbls>
+            <c:numFmt formatCode="-#,##0;;;" sourceLinked="0"/>
+            <c:spPr>
+              <a:noFill/>
+              <a:ln>
+                <a:noFill/>
+              </a:ln>
+            </c:spPr>
+            <c:txPr>
+              <a:bodyPr/>
+              <a:lstStyle/>
+              <a:p>
+                <a:pPr>
+                  <a:defRPr>
+                    <a:solidFill>
+                      <a:schemeClr val="bg1"/>
+                    </a:solidFill>
+                  </a:defRPr>
+                </a:pPr>
+                <a:endParaRPr lang="en-GB"/>
+              </a:p>
+            </c:txPr>
+            <c:dLblPos val="ctr"/>
+            <c:showLegendKey val="0"/>
+            <c:showVal val="1"/>
+            <c:showCatName val="0"/>
+            <c:showSerName val="0"/>
+            <c:showPercent val="0"/>
+            <c:showBubbleSize val="0"/>
+          </c:dLbls>
+          <c:cat>
+            <c:strRef>
+              <c:f>Sheet1!$A$2:$A$6</c:f>
+              <c:strCache>
+                <c:ptCount val="5"/>
+                <c:pt idx="0">
+                  <c:v>2025 profit</c:v>
+                </c:pt>
+                <c:pt idx="1">
+                  <c:v>Volume</c:v>
+                </c:pt>
+                <c:pt idx="2">
+                  <c:v>Price</c:v>
+                </c:pt>
+                <c:pt idx="3">
+                  <c:v>Costs</c:v>
+                </c:pt>
+                <c:pt idx="4">
+                  <c:v>2026 profit</c:v>
+                </c:pt>
+              </c:strCache>
+            </c:strRef>
+          </c:cat>
+          <c:val>
+            <c:numRef>
+              <c:f>Sheet1!$E$2:$E$6</c:f>
+              <c:numCache>
+                <c:formatCode>0</c:formatCode>
+                <c:ptCount val="5"/>
+                <c:pt idx="0">
+                  <c:v>0.0</c:v>
+                </c:pt>
+                <c:pt idx="1">
+                  <c:v>0.0</c:v>
+                </c:pt>
+                <c:pt idx="2">
+                  <c:v>0.0</c:v>
+                </c:pt>
+                <c:pt idx="3">
+                  <c:v>8.0</c:v>
+                </c:pt>
+                <c:pt idx="4">
+                  <c:v>0.0</c:v>
                 </c:pt>
               </c:numCache>
             </c:numRef>
@@ -1695,6 +1812,14 @@
         <c:crosses val="autoZero"/>
       </c:valAx>
     </c:plotArea>
+    <c:legend>
+      <c:legendPos val="b"/>
+      <c:legendEntry>
+        <c:idx val="0"/>
+        <c:delete val="1"/>
+      </c:legendEntry>
+      <c:overlay val="0"/>
+    </c:legend>
     <c:dispBlanksAs val="gap"/>
   </c:chart>
   <c:txPr>

</xml_diff>